<commit_message>
minor corrections to one slide
</commit_message>
<xml_diff>
--- a/PowerPoints/03 - Context-Free Grammars.pptx
+++ b/PowerPoints/03 - Context-Free Grammars.pptx
@@ -7843,7 +7843,7 @@
                 <a:latin typeface="Consolas" pitchFamily="49" charset="0"/>
                 <a:cs typeface="Consolas" pitchFamily="49" charset="0"/>
               </a:rPr>
-              <a:t>integerLiteral</a:t>
+              <a:t>intLiteral</a:t>
             </a:r>
             <a:r>
               <a:rPr lang="en-US" sz="1950" dirty="0">
@@ -7859,18 +7859,12 @@
               </a:rPr>
               <a:t>charLiteral</a:t>
             </a:r>
-            <a:br>
+            <a:r>
               <a:rPr lang="en-US" sz="1950" dirty="0">
                 <a:latin typeface="Consolas" pitchFamily="49" charset="0"/>
                 <a:cs typeface="Consolas" pitchFamily="49" charset="0"/>
               </a:rPr>
-            </a:br>
-            <a:r>
-              <a:rPr lang="en-US" sz="1950" dirty="0">
-                <a:latin typeface="Consolas" pitchFamily="49" charset="0"/>
-                <a:cs typeface="Consolas" pitchFamily="49" charset="0"/>
-              </a:rPr>
-              <a:t>        | </a:t>
+              <a:t> | </a:t>
             </a:r>
             <a:r>
               <a:rPr lang="en-US" sz="1950" dirty="0" err="1">
@@ -7879,27 +7873,10 @@
               </a:rPr>
               <a:t>stringLiteral</a:t>
             </a:r>
-            <a:r>
-              <a:rPr lang="en-US" sz="1950" dirty="0">
-                <a:latin typeface="Consolas" pitchFamily="49" charset="0"/>
-                <a:cs typeface="Consolas" pitchFamily="49" charset="0"/>
-              </a:rPr>
-              <a:t>  | </a:t>
-            </a:r>
-            <a:r>
-              <a:rPr lang="en-US" sz="1950" dirty="0" err="1">
-                <a:latin typeface="Consolas" pitchFamily="49" charset="0"/>
-                <a:cs typeface="Consolas" pitchFamily="49" charset="0"/>
-              </a:rPr>
-              <a:t>booleanLiteral</a:t>
-            </a:r>
-            <a:r>
-              <a:rPr lang="en-US" sz="1950" dirty="0">
-                <a:latin typeface="Consolas" pitchFamily="49" charset="0"/>
-                <a:cs typeface="Consolas" pitchFamily="49" charset="0"/>
-              </a:rPr>
-              <a:t> .</a:t>
-            </a:r>
+            <a:endParaRPr lang="en-US" sz="1950" dirty="0">
+              <a:latin typeface="Consolas" pitchFamily="49" charset="0"/>
+              <a:cs typeface="Consolas" pitchFamily="49" charset="0"/>
+            </a:endParaRPr>
           </a:p>
           <a:p>
             <a:pPr marL="182880" indent="0">
@@ -7909,18 +7886,11 @@
               <a:buNone/>
             </a:pPr>
             <a:r>
-              <a:rPr lang="en-US" sz="1950" dirty="0" err="1">
-                <a:latin typeface="Consolas" pitchFamily="49" charset="0"/>
-                <a:cs typeface="Consolas" pitchFamily="49" charset="0"/>
-              </a:rPr>
-              <a:t>booleanLiteral</a:t>
-            </a:r>
-            <a:r>
               <a:rPr lang="en-US" sz="1950" dirty="0">
                 <a:latin typeface="Consolas" pitchFamily="49" charset="0"/>
                 <a:cs typeface="Consolas" pitchFamily="49" charset="0"/>
               </a:rPr>
-              <a:t> = "true" | "false" .</a:t>
+              <a:t>        | "true" | "false" .</a:t>
             </a:r>
           </a:p>
           <a:p>
@@ -8048,6 +8018,42 @@
             </a:r>
             <a:r>
               <a:rPr lang="en-US" sz="1950" dirty="0">
+                <a:latin typeface="Consolas" pitchFamily="49" charset="0"/>
+                <a:cs typeface="Consolas" pitchFamily="49" charset="0"/>
+              </a:rPr>
+              <a:t> .</a:t>
+            </a:r>
+          </a:p>
+          <a:p>
+            <a:pPr marL="182880" indent="0">
+              <a:spcBef>
+                <a:spcPts val="600"/>
+              </a:spcBef>
+              <a:buNone/>
+            </a:pPr>
+            <a:r>
+              <a:rPr lang="en-US" sz="1950" dirty="0" err="1">
+                <a:latin typeface="Consolas" pitchFamily="49" charset="0"/>
+                <a:cs typeface="Consolas" pitchFamily="49" charset="0"/>
+              </a:rPr>
+              <a:t>constValue</a:t>
+            </a:r>
+            <a:r>
+              <a:rPr lang="en-US" sz="1950" dirty="0">
+                <a:latin typeface="Consolas" pitchFamily="49" charset="0"/>
+                <a:cs typeface="Consolas" pitchFamily="49" charset="0"/>
+              </a:rPr>
+              <a:t> = ( [ "-" ] literal ) | </a:t>
+            </a:r>
+            <a:r>
+              <a:rPr lang="en-US" sz="1950" dirty="0" err="1">
+                <a:latin typeface="Consolas" pitchFamily="49" charset="0"/>
+                <a:cs typeface="Consolas" pitchFamily="49" charset="0"/>
+              </a:rPr>
+              <a:t>constId</a:t>
+            </a:r>
+            <a:r>
+              <a:rPr lang="en-US" sz="1950">
                 <a:latin typeface="Consolas" pitchFamily="49" charset="0"/>
                 <a:cs typeface="Consolas" pitchFamily="49" charset="0"/>
               </a:rPr>

</xml_diff>